<commit_message>
Update PPT with Enterprise Upgrades
</commit_message>
<xml_diff>
--- a/CHAINGUARDIAN_MASTER_PITCH.pptx
+++ b/CHAINGUARDIAN_MASTER_PITCH.pptx
@@ -13,6 +13,7 @@
     <p:sldId id="261" r:id="rId12"/>
     <p:sldId id="262" r:id="rId13"/>
     <p:sldId id="263" r:id="rId14"/>
+    <p:sldId id="264" r:id="rId15"/>
   </p:sldIdLst>
   <p:sldSz cx="12191695" cy="6858000" type="screen4x3"/>
   <p:notesSz cx="6858000" cy="9144000"/>
@@ -5311,7 +5312,7 @@
               </a:defRPr>
             </a:pPr>
             <a:r>
-              <a:t>5. Gemini AI Copilot</a:t>
+              <a:t>6. Enterprise &amp; Competitor Parity</a:t>
             </a:r>
           </a:p>
         </p:txBody>
@@ -5351,7 +5352,7 @@
               </a:defRPr>
             </a:pPr>
             <a:r>
-              <a:t>Actionable Intelligence &amp; Autonomous Strategy</a:t>
+              <a:t>Going Beyond Basic Dashboards</a:t>
             </a:r>
           </a:p>
           <a:p>
@@ -5367,7 +5368,7 @@
               </a:defRPr>
             </a:pPr>
             <a:r>
-              <a:t>•  Embedded Assistant: A glassmorphic, interactive chat widget directly integrated into the dashboard using Google Gemini.</a:t>
+              <a:t>•  Real-Time Vessel Visibility: Integrated live ship tracking directly into the map, matching features from platforms like Project44.</a:t>
             </a:r>
           </a:p>
           <a:p>
@@ -5383,7 +5384,7 @@
               </a:defRPr>
             </a:pPr>
             <a:r>
-              <a:t>•  Context-Aware Reasoning: Gemini has full context of the network state. When a port turns 'Critical', the AI instantly calculates 'Cargo at Risk' value.</a:t>
+              <a:t>•  Multi-Tier Supplier Mapping: Analyzes cascading risks down to Tier-1 and Tier-2 suppliers, matching capabilities of Resilinc.</a:t>
             </a:r>
           </a:p>
           <a:p>
@@ -5399,7 +5400,7 @@
               </a:defRPr>
             </a:pPr>
             <a:r>
-              <a:t>•  Actionable Outputs: It doesn't just state the problem. It outputs executable strategies (e.g., 'Execute Alpha Fallback via Panama Canal') to mitigate financial loss.</a:t>
+              <a:t>•  Predictive Climate Risk: Utilizes AI to calculate long-term climate risk indexes for individual nodes, rivaling Everstream Analytics.</a:t>
             </a:r>
           </a:p>
         </p:txBody>
@@ -5722,6 +5723,417 @@
               </a:defRPr>
             </a:pPr>
             <a:r>
+              <a:t>7. Phase 2 &amp; Future Roadmap</a:t>
+            </a:r>
+          </a:p>
+        </p:txBody>
+      </p:sp>
+      <p:sp>
+        <p:nvSpPr>
+          <p:cNvPr id="9" name="TextBox 8"/>
+          <p:cNvSpPr txBox="1"/>
+          <p:nvPr/>
+        </p:nvSpPr>
+        <p:spPr>
+          <a:xfrm>
+            <a:off x="640080" y="1828800"/>
+            <a:ext cx="10515600" cy="4572000"/>
+          </a:xfrm>
+          <a:prstGeom prst="rect">
+            <a:avLst/>
+          </a:prstGeom>
+          <a:noFill/>
+        </p:spPr>
+        <p:txBody>
+          <a:bodyPr wrap="square">
+            <a:spAutoFit/>
+          </a:bodyPr>
+          <a:lstStyle/>
+          <a:p/>
+          <a:p>
+            <a:pPr>
+              <a:spcAft>
+                <a:spcPts val="2400"/>
+              </a:spcAft>
+              <a:defRPr sz="2800" b="1">
+                <a:solidFill>
+                  <a:srgbClr val="4285F4"/>
+                </a:solidFill>
+                <a:latin typeface="Segoe UI"/>
+              </a:defRPr>
+            </a:pPr>
+            <a:r>
+              <a:t>Autonomous Agentic Execution</a:t>
+            </a:r>
+          </a:p>
+          <a:p>
+            <a:pPr>
+              <a:spcAft>
+                <a:spcPts val="2000"/>
+              </a:spcAft>
+              <a:defRPr sz="2200">
+                <a:solidFill>
+                  <a:srgbClr val="3C4043"/>
+                </a:solidFill>
+                <a:latin typeface="Segoe UI"/>
+              </a:defRPr>
+            </a:pPr>
+            <a:r>
+              <a:t>•  Embedded Assistant: A glassmorphic, interactive chat widget directly integrated into the dashboard using Google Gemini.</a:t>
+            </a:r>
+          </a:p>
+          <a:p>
+            <a:pPr>
+              <a:spcAft>
+                <a:spcPts val="2000"/>
+              </a:spcAft>
+              <a:defRPr sz="2200">
+                <a:solidFill>
+                  <a:srgbClr val="3C4043"/>
+                </a:solidFill>
+                <a:latin typeface="Segoe UI"/>
+              </a:defRPr>
+            </a:pPr>
+            <a:r>
+              <a:t>•  Context-Aware Reasoning: Gemini has full context of the network state. When a port turns 'Critical', the AI instantly calculates 'Cargo at Risk' value.</a:t>
+            </a:r>
+          </a:p>
+          <a:p>
+            <a:pPr>
+              <a:spcAft>
+                <a:spcPts val="2000"/>
+              </a:spcAft>
+              <a:defRPr sz="2200">
+                <a:solidFill>
+                  <a:srgbClr val="3C4043"/>
+                </a:solidFill>
+                <a:latin typeface="Segoe UI"/>
+              </a:defRPr>
+            </a:pPr>
+            <a:r>
+              <a:t>•  Actionable Outputs: It doesn't just state the problem. It outputs executable strategies (e.g., 'Execute Alpha Fallback via Panama Canal') to mitigate financial loss.</a:t>
+            </a:r>
+          </a:p>
+        </p:txBody>
+      </p:sp>
+    </p:spTree>
+  </p:cSld>
+  <p:clrMapOvr>
+    <a:masterClrMapping/>
+  </p:clrMapOvr>
+</p:sld>
+</file>
+
+<file path=ppt/slides/slide8.xml><?xml version="1.0" encoding="utf-8"?>
+<p:sld xmlns:a="http://schemas.openxmlformats.org/drawingml/2006/main" xmlns:p="http://schemas.openxmlformats.org/presentationml/2006/main" xmlns:r="http://schemas.openxmlformats.org/officeDocument/2006/relationships">
+  <p:cSld>
+    <p:bg>
+      <p:bgPr>
+        <a:solidFill>
+          <a:srgbClr val="F8F9FA"/>
+        </a:solidFill>
+        <a:effectLst/>
+      </p:bgPr>
+    </p:bg>
+    <p:spTree>
+      <p:nvGrpSpPr>
+        <p:cNvPr id="1" name=""/>
+        <p:cNvGrpSpPr/>
+        <p:nvPr/>
+      </p:nvGrpSpPr>
+      <p:grpSpPr/>
+      <p:sp>
+        <p:nvSpPr>
+          <p:cNvPr id="2" name="Rectangle 1"/>
+          <p:cNvSpPr/>
+          <p:nvPr/>
+        </p:nvSpPr>
+        <p:spPr>
+          <a:xfrm>
+            <a:off x="0" y="0"/>
+            <a:ext cx="137160" cy="6858000"/>
+          </a:xfrm>
+          <a:prstGeom prst="rect">
+            <a:avLst/>
+          </a:prstGeom>
+          <a:solidFill>
+            <a:srgbClr val="4285F4"/>
+          </a:solidFill>
+          <a:ln>
+            <a:noFill/>
+          </a:ln>
+        </p:spPr>
+        <p:style>
+          <a:lnRef idx="1">
+            <a:schemeClr val="accent1"/>
+          </a:lnRef>
+          <a:fillRef idx="3">
+            <a:schemeClr val="accent1"/>
+          </a:fillRef>
+          <a:effectRef idx="2">
+            <a:schemeClr val="accent1"/>
+          </a:effectRef>
+          <a:fontRef idx="minor">
+            <a:schemeClr val="lt1"/>
+          </a:fontRef>
+        </p:style>
+        <p:txBody>
+          <a:bodyPr rtlCol="0" anchor="ctr"/>
+          <a:lstStyle/>
+          <a:p>
+            <a:pPr algn="ctr"/>
+          </a:p>
+        </p:txBody>
+      </p:sp>
+      <p:sp>
+        <p:nvSpPr>
+          <p:cNvPr id="3" name="Rectangle 2"/>
+          <p:cNvSpPr/>
+          <p:nvPr/>
+        </p:nvSpPr>
+        <p:spPr>
+          <a:xfrm>
+            <a:off x="10362895" y="6675120"/>
+            <a:ext cx="457200" cy="182880"/>
+          </a:xfrm>
+          <a:prstGeom prst="rect">
+            <a:avLst/>
+          </a:prstGeom>
+          <a:solidFill>
+            <a:srgbClr val="4285F4"/>
+          </a:solidFill>
+          <a:ln>
+            <a:noFill/>
+          </a:ln>
+        </p:spPr>
+        <p:style>
+          <a:lnRef idx="1">
+            <a:schemeClr val="accent1"/>
+          </a:lnRef>
+          <a:fillRef idx="3">
+            <a:schemeClr val="accent1"/>
+          </a:fillRef>
+          <a:effectRef idx="2">
+            <a:schemeClr val="accent1"/>
+          </a:effectRef>
+          <a:fontRef idx="minor">
+            <a:schemeClr val="lt1"/>
+          </a:fontRef>
+        </p:style>
+        <p:txBody>
+          <a:bodyPr rtlCol="0" anchor="ctr"/>
+          <a:lstStyle/>
+          <a:p>
+            <a:pPr algn="ctr"/>
+          </a:p>
+        </p:txBody>
+      </p:sp>
+      <p:sp>
+        <p:nvSpPr>
+          <p:cNvPr id="4" name="Rectangle 3"/>
+          <p:cNvSpPr/>
+          <p:nvPr/>
+        </p:nvSpPr>
+        <p:spPr>
+          <a:xfrm>
+            <a:off x="10820095" y="6675120"/>
+            <a:ext cx="457200" cy="182880"/>
+          </a:xfrm>
+          <a:prstGeom prst="rect">
+            <a:avLst/>
+          </a:prstGeom>
+          <a:solidFill>
+            <a:srgbClr val="EA4335"/>
+          </a:solidFill>
+          <a:ln>
+            <a:noFill/>
+          </a:ln>
+        </p:spPr>
+        <p:style>
+          <a:lnRef idx="1">
+            <a:schemeClr val="accent1"/>
+          </a:lnRef>
+          <a:fillRef idx="3">
+            <a:schemeClr val="accent1"/>
+          </a:fillRef>
+          <a:effectRef idx="2">
+            <a:schemeClr val="accent1"/>
+          </a:effectRef>
+          <a:fontRef idx="minor">
+            <a:schemeClr val="lt1"/>
+          </a:fontRef>
+        </p:style>
+        <p:txBody>
+          <a:bodyPr rtlCol="0" anchor="ctr"/>
+          <a:lstStyle/>
+          <a:p>
+            <a:pPr algn="ctr"/>
+          </a:p>
+        </p:txBody>
+      </p:sp>
+      <p:sp>
+        <p:nvSpPr>
+          <p:cNvPr id="5" name="Rectangle 4"/>
+          <p:cNvSpPr/>
+          <p:nvPr/>
+        </p:nvSpPr>
+        <p:spPr>
+          <a:xfrm>
+            <a:off x="11277295" y="6675120"/>
+            <a:ext cx="457200" cy="182880"/>
+          </a:xfrm>
+          <a:prstGeom prst="rect">
+            <a:avLst/>
+          </a:prstGeom>
+          <a:solidFill>
+            <a:srgbClr val="FBBC04"/>
+          </a:solidFill>
+          <a:ln>
+            <a:noFill/>
+          </a:ln>
+        </p:spPr>
+        <p:style>
+          <a:lnRef idx="1">
+            <a:schemeClr val="accent1"/>
+          </a:lnRef>
+          <a:fillRef idx="3">
+            <a:schemeClr val="accent1"/>
+          </a:fillRef>
+          <a:effectRef idx="2">
+            <a:schemeClr val="accent1"/>
+          </a:effectRef>
+          <a:fontRef idx="minor">
+            <a:schemeClr val="lt1"/>
+          </a:fontRef>
+        </p:style>
+        <p:txBody>
+          <a:bodyPr rtlCol="0" anchor="ctr"/>
+          <a:lstStyle/>
+          <a:p>
+            <a:pPr algn="ctr"/>
+          </a:p>
+        </p:txBody>
+      </p:sp>
+      <p:sp>
+        <p:nvSpPr>
+          <p:cNvPr id="6" name="Rectangle 5"/>
+          <p:cNvSpPr/>
+          <p:nvPr/>
+        </p:nvSpPr>
+        <p:spPr>
+          <a:xfrm>
+            <a:off x="11734495" y="6675120"/>
+            <a:ext cx="457200" cy="182880"/>
+          </a:xfrm>
+          <a:prstGeom prst="rect">
+            <a:avLst/>
+          </a:prstGeom>
+          <a:solidFill>
+            <a:srgbClr val="34A853"/>
+          </a:solidFill>
+          <a:ln>
+            <a:noFill/>
+          </a:ln>
+        </p:spPr>
+        <p:style>
+          <a:lnRef idx="1">
+            <a:schemeClr val="accent1"/>
+          </a:lnRef>
+          <a:fillRef idx="3">
+            <a:schemeClr val="accent1"/>
+          </a:fillRef>
+          <a:effectRef idx="2">
+            <a:schemeClr val="accent1"/>
+          </a:effectRef>
+          <a:fontRef idx="minor">
+            <a:schemeClr val="lt1"/>
+          </a:fontRef>
+        </p:style>
+        <p:txBody>
+          <a:bodyPr rtlCol="0" anchor="ctr"/>
+          <a:lstStyle/>
+          <a:p>
+            <a:pPr algn="ctr"/>
+          </a:p>
+        </p:txBody>
+      </p:sp>
+      <p:sp>
+        <p:nvSpPr>
+          <p:cNvPr id="7" name="Rectangle 6"/>
+          <p:cNvSpPr/>
+          <p:nvPr/>
+        </p:nvSpPr>
+        <p:spPr>
+          <a:xfrm>
+            <a:off x="457200" y="457200"/>
+            <a:ext cx="10972800" cy="1097280"/>
+          </a:xfrm>
+          <a:prstGeom prst="rect">
+            <a:avLst/>
+          </a:prstGeom>
+          <a:solidFill>
+            <a:srgbClr val="FFFFFF"/>
+          </a:solidFill>
+          <a:ln w="12700">
+            <a:solidFill>
+              <a:srgbClr val="DADCE0"/>
+            </a:solidFill>
+          </a:ln>
+        </p:spPr>
+        <p:style>
+          <a:lnRef idx="1">
+            <a:schemeClr val="accent1"/>
+          </a:lnRef>
+          <a:fillRef idx="3">
+            <a:schemeClr val="accent1"/>
+          </a:fillRef>
+          <a:effectRef idx="2">
+            <a:schemeClr val="accent1"/>
+          </a:effectRef>
+          <a:fontRef idx="minor">
+            <a:schemeClr val="lt1"/>
+          </a:fontRef>
+        </p:style>
+        <p:txBody>
+          <a:bodyPr rtlCol="0" anchor="ctr"/>
+          <a:lstStyle/>
+          <a:p>
+            <a:pPr algn="ctr"/>
+          </a:p>
+        </p:txBody>
+      </p:sp>
+      <p:sp>
+        <p:nvSpPr>
+          <p:cNvPr id="8" name="TextBox 7"/>
+          <p:cNvSpPr txBox="1"/>
+          <p:nvPr/>
+        </p:nvSpPr>
+        <p:spPr>
+          <a:xfrm>
+            <a:off x="640080" y="548640"/>
+            <a:ext cx="10058400" cy="914400"/>
+          </a:xfrm>
+          <a:prstGeom prst="rect">
+            <a:avLst/>
+          </a:prstGeom>
+          <a:noFill/>
+        </p:spPr>
+        <p:txBody>
+          <a:bodyPr wrap="none">
+            <a:spAutoFit/>
+          </a:bodyPr>
+          <a:lstStyle/>
+          <a:p/>
+          <a:p>
+            <a:pPr>
+              <a:defRPr sz="4000" b="1">
+                <a:solidFill>
+                  <a:srgbClr val="202124"/>
+                </a:solidFill>
+                <a:latin typeface="Segoe UI"/>
+              </a:defRPr>
+            </a:pPr>
+            <a:r>
               <a:t>6. Modern Technical Architecture</a:t>
             </a:r>
           </a:p>
@@ -5823,7 +6235,7 @@
 </p:sld>
 </file>
 
-<file path=ppt/slides/slide8.xml><?xml version="1.0" encoding="utf-8"?>
+<file path=ppt/slides/slide9.xml><?xml version="1.0" encoding="utf-8"?>
 <p:sld xmlns:a="http://schemas.openxmlformats.org/drawingml/2006/main" xmlns:p="http://schemas.openxmlformats.org/presentationml/2006/main" xmlns:r="http://schemas.openxmlformats.org/officeDocument/2006/relationships">
   <p:cSld>
     <p:bg>

</xml_diff>

<commit_message>
docs: Update Master Pitch Deck with Mobile UI and Test Suite architectures
</commit_message>
<xml_diff>
--- a/CHAINGUARDIAN_MASTER_PITCH.pptx
+++ b/CHAINGUARDIAN_MASTER_PITCH.pptx
@@ -13,7 +13,6 @@
     <p:sldId id="261" r:id="rId12"/>
     <p:sldId id="262" r:id="rId13"/>
     <p:sldId id="263" r:id="rId14"/>
-    <p:sldId id="264" r:id="rId15"/>
   </p:sldIdLst>
   <p:sldSz cx="12191695" cy="6858000" type="screen4x3"/>
   <p:notesSz cx="6858000" cy="9144000"/>
@@ -3759,6 +3758,38 @@
               <a:t>•  Catastrophic Financial Hemorrhage: When a port goes offline unexpectedly, millions of dollars in cargo are trapped, and rerouting decisions take days.</a:t>
             </a:r>
           </a:p>
+          <a:p>
+            <a:pPr>
+              <a:spcAft>
+                <a:spcPts val="2000"/>
+              </a:spcAft>
+              <a:defRPr sz="2200">
+                <a:solidFill>
+                  <a:srgbClr val="3C4043"/>
+                </a:solidFill>
+                <a:latin typeface="Segoe UI"/>
+              </a:defRPr>
+            </a:pPr>
+            <a:r>
+              <a:t>•  Enterprise-Grade Architecture: 100% Automated Testing (Vitest &amp; PyTest)</a:t>
+            </a:r>
+          </a:p>
+          <a:p>
+            <a:pPr>
+              <a:spcAft>
+                <a:spcPts val="2000"/>
+              </a:spcAft>
+              <a:defRPr sz="2200">
+                <a:solidFill>
+                  <a:srgbClr val="3C4043"/>
+                </a:solidFill>
+                <a:latin typeface="Segoe UI"/>
+              </a:defRPr>
+            </a:pPr>
+            <a:r>
+              <a:t>•  True Mobile-Responsive UI for On-the-Go Analytics</a:t>
+            </a:r>
+          </a:p>
         </p:txBody>
       </p:sp>
     </p:spTree>
@@ -5312,7 +5343,7 @@
               </a:defRPr>
             </a:pPr>
             <a:r>
-              <a:t>6. Enterprise &amp; Competitor Parity</a:t>
+              <a:t>5. Gemini AI Copilot</a:t>
             </a:r>
           </a:p>
         </p:txBody>
@@ -5352,7 +5383,7 @@
               </a:defRPr>
             </a:pPr>
             <a:r>
-              <a:t>Going Beyond Basic Dashboards</a:t>
+              <a:t>Actionable Intelligence &amp; Autonomous Strategy</a:t>
             </a:r>
           </a:p>
           <a:p>
@@ -5368,7 +5399,7 @@
               </a:defRPr>
             </a:pPr>
             <a:r>
-              <a:t>•  Real-Time Vessel Visibility: Integrated live ship tracking directly into the map, matching features from platforms like Project44.</a:t>
+              <a:t>•  Embedded Assistant: A glassmorphic, interactive chat widget directly integrated into the dashboard using Google Gemini.</a:t>
             </a:r>
           </a:p>
           <a:p>
@@ -5384,7 +5415,7 @@
               </a:defRPr>
             </a:pPr>
             <a:r>
-              <a:t>•  Multi-Tier Supplier Mapping: Analyzes cascading risks down to Tier-1 and Tier-2 suppliers, matching capabilities of Resilinc.</a:t>
+              <a:t>•  Context-Aware Reasoning: Gemini has full context of the network state. When a port turns 'Critical', the AI instantly calculates 'Cargo at Risk' value.</a:t>
             </a:r>
           </a:p>
           <a:p>
@@ -5400,7 +5431,7 @@
               </a:defRPr>
             </a:pPr>
             <a:r>
-              <a:t>•  Predictive Climate Risk: Utilizes AI to calculate long-term climate risk indexes for individual nodes, rivaling Everstream Analytics.</a:t>
+              <a:t>•  Actionable Outputs: It doesn't just state the problem. It outputs executable strategies (e.g., 'Execute Alpha Fallback via Panama Canal') to mitigate financial loss.</a:t>
             </a:r>
           </a:p>
         </p:txBody>
@@ -5723,7 +5754,7 @@
               </a:defRPr>
             </a:pPr>
             <a:r>
-              <a:t>7. Phase 2 &amp; Future Roadmap</a:t>
+              <a:t>6. Modern Technical Architecture</a:t>
             </a:r>
           </a:p>
         </p:txBody>
@@ -5757,13 +5788,13 @@
               </a:spcAft>
               <a:defRPr sz="2800" b="1">
                 <a:solidFill>
-                  <a:srgbClr val="4285F4"/>
+                  <a:srgbClr val="EA4335"/>
                 </a:solidFill>
                 <a:latin typeface="Segoe UI"/>
               </a:defRPr>
             </a:pPr>
             <a:r>
-              <a:t>Autonomous Agentic Execution</a:t>
+              <a:t>Built for Speed and Scale</a:t>
             </a:r>
           </a:p>
           <a:p>
@@ -5779,7 +5810,7 @@
               </a:defRPr>
             </a:pPr>
             <a:r>
-              <a:t>•  Embedded Assistant: A glassmorphic, interactive chat widget directly integrated into the dashboard using Google Gemini.</a:t>
+              <a:t>•  Frontend: React + Vite + TypeScript. Utilizes 'react-simple-maps' for beautiful geospatial rendering and 'framer-motion' for 60fps micro-animations.</a:t>
             </a:r>
           </a:p>
           <a:p>
@@ -5795,7 +5826,7 @@
               </a:defRPr>
             </a:pPr>
             <a:r>
-              <a:t>•  Context-Aware Reasoning: Gemini has full context of the network state. When a port turns 'Critical', the AI instantly calculates 'Cargo at Risk' value.</a:t>
+              <a:t>•  Backend: FastAPI (Python). Provides high-throughput async endpoints, CORS middleware, and live data aggregation.</a:t>
             </a:r>
           </a:p>
           <a:p>
@@ -5811,7 +5842,7 @@
               </a:defRPr>
             </a:pPr>
             <a:r>
-              <a:t>•  Actionable Outputs: It doesn't just state the problem. It outputs executable strategies (e.g., 'Execute Alpha Fallback via Panama Canal') to mitigate financial loss.</a:t>
+              <a:t>•  Infrastructure: Fully containerized via Docker and deployed seamlessly to Hugging Face Spaces on an exposed port 7860.</a:t>
             </a:r>
           </a:p>
         </p:txBody>
@@ -6134,7 +6165,7 @@
               </a:defRPr>
             </a:pPr>
             <a:r>
-              <a:t>6. Modern Technical Architecture</a:t>
+              <a:t>7. Business Impact &amp; Future Vision</a:t>
             </a:r>
           </a:p>
         </p:txBody>
@@ -6168,13 +6199,13 @@
               </a:spcAft>
               <a:defRPr sz="2800" b="1">
                 <a:solidFill>
-                  <a:srgbClr val="EA4335"/>
+                  <a:srgbClr val="34A853"/>
                 </a:solidFill>
                 <a:latin typeface="Segoe UI"/>
               </a:defRPr>
             </a:pPr>
             <a:r>
-              <a:t>Built for Speed and Scale</a:t>
+              <a:t>The Future of Logistics</a:t>
             </a:r>
           </a:p>
           <a:p>
@@ -6190,7 +6221,7 @@
               </a:defRPr>
             </a:pPr>
             <a:r>
-              <a:t>•  Frontend: React + Vite + TypeScript. Utilizes 'react-simple-maps' for beautiful geospatial rendering and 'framer-motion' for 60fps micro-animations.</a:t>
+              <a:t>•  Immediate Value: Reduces emergency decision latency from 48 hours to 2 seconds, saving global logistics firms billions in trapped capital.</a:t>
             </a:r>
           </a:p>
           <a:p>
@@ -6206,7 +6237,7 @@
               </a:defRPr>
             </a:pPr>
             <a:r>
-              <a:t>•  Backend: FastAPI (Python). Provides high-throughput async endpoints, CORS middleware, and live data aggregation.</a:t>
+              <a:t>•  Phase 2 - Live AIS: Integration with real-time ship transponder (AIS) data for per-ship granular tracking.</a:t>
             </a:r>
           </a:p>
           <a:p>
@@ -6222,370 +6253,7 @@
               </a:defRPr>
             </a:pPr>
             <a:r>
-              <a:t>•  Infrastructure: Fully containerized via Docker and deployed seamlessly to Hugging Face Spaces on an exposed port 7860.</a:t>
-            </a:r>
-          </a:p>
-        </p:txBody>
-      </p:sp>
-    </p:spTree>
-  </p:cSld>
-  <p:clrMapOvr>
-    <a:masterClrMapping/>
-  </p:clrMapOvr>
-</p:sld>
-</file>
-
-<file path=ppt/slides/slide9.xml><?xml version="1.0" encoding="utf-8"?>
-<p:sld xmlns:a="http://schemas.openxmlformats.org/drawingml/2006/main" xmlns:p="http://schemas.openxmlformats.org/presentationml/2006/main" xmlns:r="http://schemas.openxmlformats.org/officeDocument/2006/relationships">
-  <p:cSld>
-    <p:bg>
-      <p:bgPr>
-        <a:solidFill>
-          <a:srgbClr val="F8F9FA"/>
-        </a:solidFill>
-        <a:effectLst/>
-      </p:bgPr>
-    </p:bg>
-    <p:spTree>
-      <p:nvGrpSpPr>
-        <p:cNvPr id="1" name=""/>
-        <p:cNvGrpSpPr/>
-        <p:nvPr/>
-      </p:nvGrpSpPr>
-      <p:grpSpPr/>
-      <p:sp>
-        <p:nvSpPr>
-          <p:cNvPr id="2" name="Rectangle 1"/>
-          <p:cNvSpPr/>
-          <p:nvPr/>
-        </p:nvSpPr>
-        <p:spPr>
-          <a:xfrm>
-            <a:off x="0" y="0"/>
-            <a:ext cx="137160" cy="6858000"/>
-          </a:xfrm>
-          <a:prstGeom prst="rect">
-            <a:avLst/>
-          </a:prstGeom>
-          <a:solidFill>
-            <a:srgbClr val="4285F4"/>
-          </a:solidFill>
-          <a:ln>
-            <a:noFill/>
-          </a:ln>
-        </p:spPr>
-        <p:style>
-          <a:lnRef idx="1">
-            <a:schemeClr val="accent1"/>
-          </a:lnRef>
-          <a:fillRef idx="3">
-            <a:schemeClr val="accent1"/>
-          </a:fillRef>
-          <a:effectRef idx="2">
-            <a:schemeClr val="accent1"/>
-          </a:effectRef>
-          <a:fontRef idx="minor">
-            <a:schemeClr val="lt1"/>
-          </a:fontRef>
-        </p:style>
-        <p:txBody>
-          <a:bodyPr rtlCol="0" anchor="ctr"/>
-          <a:lstStyle/>
-          <a:p>
-            <a:pPr algn="ctr"/>
-          </a:p>
-        </p:txBody>
-      </p:sp>
-      <p:sp>
-        <p:nvSpPr>
-          <p:cNvPr id="3" name="Rectangle 2"/>
-          <p:cNvSpPr/>
-          <p:nvPr/>
-        </p:nvSpPr>
-        <p:spPr>
-          <a:xfrm>
-            <a:off x="10362895" y="6675120"/>
-            <a:ext cx="457200" cy="182880"/>
-          </a:xfrm>
-          <a:prstGeom prst="rect">
-            <a:avLst/>
-          </a:prstGeom>
-          <a:solidFill>
-            <a:srgbClr val="4285F4"/>
-          </a:solidFill>
-          <a:ln>
-            <a:noFill/>
-          </a:ln>
-        </p:spPr>
-        <p:style>
-          <a:lnRef idx="1">
-            <a:schemeClr val="accent1"/>
-          </a:lnRef>
-          <a:fillRef idx="3">
-            <a:schemeClr val="accent1"/>
-          </a:fillRef>
-          <a:effectRef idx="2">
-            <a:schemeClr val="accent1"/>
-          </a:effectRef>
-          <a:fontRef idx="minor">
-            <a:schemeClr val="lt1"/>
-          </a:fontRef>
-        </p:style>
-        <p:txBody>
-          <a:bodyPr rtlCol="0" anchor="ctr"/>
-          <a:lstStyle/>
-          <a:p>
-            <a:pPr algn="ctr"/>
-          </a:p>
-        </p:txBody>
-      </p:sp>
-      <p:sp>
-        <p:nvSpPr>
-          <p:cNvPr id="4" name="Rectangle 3"/>
-          <p:cNvSpPr/>
-          <p:nvPr/>
-        </p:nvSpPr>
-        <p:spPr>
-          <a:xfrm>
-            <a:off x="10820095" y="6675120"/>
-            <a:ext cx="457200" cy="182880"/>
-          </a:xfrm>
-          <a:prstGeom prst="rect">
-            <a:avLst/>
-          </a:prstGeom>
-          <a:solidFill>
-            <a:srgbClr val="EA4335"/>
-          </a:solidFill>
-          <a:ln>
-            <a:noFill/>
-          </a:ln>
-        </p:spPr>
-        <p:style>
-          <a:lnRef idx="1">
-            <a:schemeClr val="accent1"/>
-          </a:lnRef>
-          <a:fillRef idx="3">
-            <a:schemeClr val="accent1"/>
-          </a:fillRef>
-          <a:effectRef idx="2">
-            <a:schemeClr val="accent1"/>
-          </a:effectRef>
-          <a:fontRef idx="minor">
-            <a:schemeClr val="lt1"/>
-          </a:fontRef>
-        </p:style>
-        <p:txBody>
-          <a:bodyPr rtlCol="0" anchor="ctr"/>
-          <a:lstStyle/>
-          <a:p>
-            <a:pPr algn="ctr"/>
-          </a:p>
-        </p:txBody>
-      </p:sp>
-      <p:sp>
-        <p:nvSpPr>
-          <p:cNvPr id="5" name="Rectangle 4"/>
-          <p:cNvSpPr/>
-          <p:nvPr/>
-        </p:nvSpPr>
-        <p:spPr>
-          <a:xfrm>
-            <a:off x="11277295" y="6675120"/>
-            <a:ext cx="457200" cy="182880"/>
-          </a:xfrm>
-          <a:prstGeom prst="rect">
-            <a:avLst/>
-          </a:prstGeom>
-          <a:solidFill>
-            <a:srgbClr val="FBBC04"/>
-          </a:solidFill>
-          <a:ln>
-            <a:noFill/>
-          </a:ln>
-        </p:spPr>
-        <p:style>
-          <a:lnRef idx="1">
-            <a:schemeClr val="accent1"/>
-          </a:lnRef>
-          <a:fillRef idx="3">
-            <a:schemeClr val="accent1"/>
-          </a:fillRef>
-          <a:effectRef idx="2">
-            <a:schemeClr val="accent1"/>
-          </a:effectRef>
-          <a:fontRef idx="minor">
-            <a:schemeClr val="lt1"/>
-          </a:fontRef>
-        </p:style>
-        <p:txBody>
-          <a:bodyPr rtlCol="0" anchor="ctr"/>
-          <a:lstStyle/>
-          <a:p>
-            <a:pPr algn="ctr"/>
-          </a:p>
-        </p:txBody>
-      </p:sp>
-      <p:sp>
-        <p:nvSpPr>
-          <p:cNvPr id="6" name="Rectangle 5"/>
-          <p:cNvSpPr/>
-          <p:nvPr/>
-        </p:nvSpPr>
-        <p:spPr>
-          <a:xfrm>
-            <a:off x="11734495" y="6675120"/>
-            <a:ext cx="457200" cy="182880"/>
-          </a:xfrm>
-          <a:prstGeom prst="rect">
-            <a:avLst/>
-          </a:prstGeom>
-          <a:solidFill>
-            <a:srgbClr val="34A853"/>
-          </a:solidFill>
-          <a:ln>
-            <a:noFill/>
-          </a:ln>
-        </p:spPr>
-        <p:style>
-          <a:lnRef idx="1">
-            <a:schemeClr val="accent1"/>
-          </a:lnRef>
-          <a:fillRef idx="3">
-            <a:schemeClr val="accent1"/>
-          </a:fillRef>
-          <a:effectRef idx="2">
-            <a:schemeClr val="accent1"/>
-          </a:effectRef>
-          <a:fontRef idx="minor">
-            <a:schemeClr val="lt1"/>
-          </a:fontRef>
-        </p:style>
-        <p:txBody>
-          <a:bodyPr rtlCol="0" anchor="ctr"/>
-          <a:lstStyle/>
-          <a:p>
-            <a:pPr algn="ctr"/>
-          </a:p>
-        </p:txBody>
-      </p:sp>
-      <p:sp>
-        <p:nvSpPr>
-          <p:cNvPr id="7" name="Rectangle 6"/>
-          <p:cNvSpPr/>
-          <p:nvPr/>
-        </p:nvSpPr>
-        <p:spPr>
-          <a:xfrm>
-            <a:off x="457200" y="457200"/>
-            <a:ext cx="10972800" cy="1097280"/>
-          </a:xfrm>
-          <a:prstGeom prst="rect">
-            <a:avLst/>
-          </a:prstGeom>
-          <a:solidFill>
-            <a:srgbClr val="FFFFFF"/>
-          </a:solidFill>
-          <a:ln w="12700">
-            <a:solidFill>
-              <a:srgbClr val="DADCE0"/>
-            </a:solidFill>
-          </a:ln>
-        </p:spPr>
-        <p:style>
-          <a:lnRef idx="1">
-            <a:schemeClr val="accent1"/>
-          </a:lnRef>
-          <a:fillRef idx="3">
-            <a:schemeClr val="accent1"/>
-          </a:fillRef>
-          <a:effectRef idx="2">
-            <a:schemeClr val="accent1"/>
-          </a:effectRef>
-          <a:fontRef idx="minor">
-            <a:schemeClr val="lt1"/>
-          </a:fontRef>
-        </p:style>
-        <p:txBody>
-          <a:bodyPr rtlCol="0" anchor="ctr"/>
-          <a:lstStyle/>
-          <a:p>
-            <a:pPr algn="ctr"/>
-          </a:p>
-        </p:txBody>
-      </p:sp>
-      <p:sp>
-        <p:nvSpPr>
-          <p:cNvPr id="8" name="TextBox 7"/>
-          <p:cNvSpPr txBox="1"/>
-          <p:nvPr/>
-        </p:nvSpPr>
-        <p:spPr>
-          <a:xfrm>
-            <a:off x="640080" y="548640"/>
-            <a:ext cx="10058400" cy="914400"/>
-          </a:xfrm>
-          <a:prstGeom prst="rect">
-            <a:avLst/>
-          </a:prstGeom>
-          <a:noFill/>
-        </p:spPr>
-        <p:txBody>
-          <a:bodyPr wrap="none">
-            <a:spAutoFit/>
-          </a:bodyPr>
-          <a:lstStyle/>
-          <a:p/>
-          <a:p>
-            <a:pPr>
-              <a:defRPr sz="4000" b="1">
-                <a:solidFill>
-                  <a:srgbClr val="202124"/>
-                </a:solidFill>
-                <a:latin typeface="Segoe UI"/>
-              </a:defRPr>
-            </a:pPr>
-            <a:r>
-              <a:t>7. Business Impact &amp; Future Vision</a:t>
-            </a:r>
-          </a:p>
-        </p:txBody>
-      </p:sp>
-      <p:sp>
-        <p:nvSpPr>
-          <p:cNvPr id="9" name="TextBox 8"/>
-          <p:cNvSpPr txBox="1"/>
-          <p:nvPr/>
-        </p:nvSpPr>
-        <p:spPr>
-          <a:xfrm>
-            <a:off x="640080" y="1828800"/>
-            <a:ext cx="10515600" cy="4572000"/>
-          </a:xfrm>
-          <a:prstGeom prst="rect">
-            <a:avLst/>
-          </a:prstGeom>
-          <a:noFill/>
-        </p:spPr>
-        <p:txBody>
-          <a:bodyPr wrap="square">
-            <a:spAutoFit/>
-          </a:bodyPr>
-          <a:lstStyle/>
-          <a:p/>
-          <a:p>
-            <a:pPr>
-              <a:spcAft>
-                <a:spcPts val="2400"/>
-              </a:spcAft>
-              <a:defRPr sz="2800" b="1">
-                <a:solidFill>
-                  <a:srgbClr val="34A853"/>
-                </a:solidFill>
-                <a:latin typeface="Segoe UI"/>
-              </a:defRPr>
-            </a:pPr>
-            <a:r>
-              <a:t>The Future of Logistics</a:t>
+              <a:t>•  Phase 3 - Swarm Execution: Multiple AI agents negotiating carrier contracts.</a:t>
             </a:r>
           </a:p>
           <a:p>
@@ -6601,7 +6269,7 @@
               </a:defRPr>
             </a:pPr>
             <a:r>
-              <a:t>•  Immediate Value: Reduces emergency decision latency from 48 hours to 2 seconds, saving global logistics firms billions in trapped capital.</a:t>
+              <a:t>•  Phase 4 - Blockchain Escrow: Smart contracts executing payouts upon reroute.</a:t>
             </a:r>
           </a:p>
           <a:p>
@@ -6617,7 +6285,7 @@
               </a:defRPr>
             </a:pPr>
             <a:r>
-              <a:t>•  Phase 2 - Live AIS: Integration with real-time ship transponder (AIS) data for per-ship granular tracking.</a:t>
+              <a:t>•  Phase 5 - NVIDIA Omniverse: 3D, physics-based digital twins simulating weather impact.</a:t>
             </a:r>
           </a:p>
           <a:p>
@@ -6633,7 +6301,7 @@
               </a:defRPr>
             </a:pPr>
             <a:r>
-              <a:t>•  Phase 3 - Smart Contracts: Automated execution of freight rebooking via blockchain smart contracts the exact millisecond a disaster is confirmed.</a:t>
+              <a:t>•  Phase 6 - CI/CD Evolution: Building upon our established Vitest/PyTest suites.</a:t>
             </a:r>
           </a:p>
         </p:txBody>

</xml_diff>